<commit_message>
Finished Slides and Script Draft 1
</commit_message>
<xml_diff>
--- a/Assessment/GAT Slides.pptx
+++ b/Assessment/GAT Slides.pptx
@@ -26,8 +26,8 @@
     <p:sldId id="274" r:id="rId17"/>
     <p:sldId id="273" r:id="rId18"/>
     <p:sldId id="275" r:id="rId19"/>
-    <p:sldId id="261" r:id="rId20"/>
-    <p:sldId id="262" r:id="rId21"/>
+    <p:sldId id="262" r:id="rId20"/>
+    <p:sldId id="261" r:id="rId21"/>
   </p:sldIdLst>
   <p:sldSz cx="12192000" cy="6858000"/>
   <p:notesSz cx="6858000" cy="9144000"/>
@@ -6934,7 +6934,7 @@
           <p:nvPr>
             <p:extLst>
               <p:ext uri="{D42A27DB-BD31-4B8C-83A1-F6EECF244321}">
-                <p14:modId xmlns:p14="http://schemas.microsoft.com/office/powerpoint/2010/main" val="3858021791"/>
+                <p14:modId xmlns:p14="http://schemas.microsoft.com/office/powerpoint/2010/main" val="1609231734"/>
               </p:ext>
             </p:extLst>
           </p:nvPr>
@@ -7073,11 +7073,14 @@
                       </a:r>
                     </a:p>
                     <a:p>
-                      <a:pPr marL="0" indent="0">
+                      <a:pPr marL="285750" indent="-285750">
                         <a:buFontTx/>
-                        <a:buNone/>
+                        <a:buChar char="-"/>
                       </a:pPr>
-                      <a:endParaRPr lang="en-GB" sz="1600" dirty="0"/>
+                      <a:r>
+                        <a:rPr lang="en-GB" sz="1600" dirty="0"/>
+                        <a:t>There are also bird tweets in the background</a:t>
+                      </a:r>
                     </a:p>
                   </a:txBody>
                   <a:tcPr/>
@@ -8645,8 +8648,13 @@
             </a:pPr>
             <a:r>
               <a:rPr lang="en-GB" sz="2000" dirty="0"/>
-              <a:t>2 separate audio sources, one for queen one for king</a:t>
-            </a:r>
+              <a:t>2 separate audio sources, one for queen one </a:t>
+            </a:r>
+            <a:r>
+              <a:rPr lang="en-GB" sz="2000"/>
+              <a:t>for troll</a:t>
+            </a:r>
+            <a:endParaRPr lang="en-GB" sz="2000" dirty="0"/>
           </a:p>
           <a:p>
             <a:pPr marL="285750" indent="-285750">
@@ -8702,7 +8710,13 @@
   <p:cSld>
     <p:spTree>
       <p:nvGrpSpPr>
-        <p:cNvPr id="1" name=""/>
+        <p:cNvPr id="1" name="">
+          <a:extLst>
+            <a:ext uri="{FF2B5EF4-FFF2-40B4-BE49-F238E27FC236}">
+              <a16:creationId xmlns:a16="http://schemas.microsoft.com/office/drawing/2014/main" id="{7C03BD2E-B010-879D-7CDC-F403EDB89F5B}"/>
+            </a:ext>
+          </a:extLst>
+        </p:cNvPr>
         <p:cNvGrpSpPr/>
         <p:nvPr/>
       </p:nvGrpSpPr>
@@ -8719,7 +8733,7 @@
           <p:cNvPr id="2" name="Title 1">
             <a:extLst>
               <a:ext uri="{FF2B5EF4-FFF2-40B4-BE49-F238E27FC236}">
-                <a16:creationId xmlns:a16="http://schemas.microsoft.com/office/drawing/2014/main" id="{4A669AEC-2DF0-2255-F587-D88A4590DD2B}"/>
+                <a16:creationId xmlns:a16="http://schemas.microsoft.com/office/drawing/2014/main" id="{A22BAA2A-442E-3E81-F11C-F674141CAC4E}"/>
               </a:ext>
             </a:extLst>
           </p:cNvPr>
@@ -8742,70 +8756,610 @@
           <a:p>
             <a:r>
               <a:rPr lang="en-GB" dirty="0"/>
-              <a:t>Sound ORIGINS</a:t>
-            </a:r>
-          </a:p>
-        </p:txBody>
-      </p:sp>
-      <p:sp>
-        <p:nvSpPr>
-          <p:cNvPr id="3" name="Content Placeholder 2">
-            <a:extLst>
-              <a:ext uri="{FF2B5EF4-FFF2-40B4-BE49-F238E27FC236}">
-                <a16:creationId xmlns:a16="http://schemas.microsoft.com/office/drawing/2014/main" id="{077BADC9-E785-AB9C-2915-D6DE1879AC85}"/>
-              </a:ext>
-            </a:extLst>
-          </p:cNvPr>
-          <p:cNvSpPr>
-            <a:spLocks noGrp="1"/>
-          </p:cNvSpPr>
-          <p:nvPr>
-            <p:ph idx="1"/>
-          </p:nvPr>
-        </p:nvSpPr>
-        <p:spPr>
-          <a:xfrm>
-            <a:off x="2093976" y="1405771"/>
-            <a:ext cx="7729728" cy="3101983"/>
-          </a:xfrm>
-        </p:spPr>
-        <p:txBody>
-          <a:bodyPr/>
-          <a:lstStyle/>
-          <a:p>
-            <a:r>
-              <a:rPr lang="en-GB" sz="2400" dirty="0"/>
-              <a:t>Most sounds were recorded by me and are listed on the Recording Details Template</a:t>
-            </a:r>
-          </a:p>
-          <a:p>
-            <a:pPr marL="0" indent="0">
-              <a:buNone/>
-            </a:pPr>
-            <a:endParaRPr lang="en-GB" sz="2400" dirty="0"/>
-          </a:p>
-          <a:p>
-            <a:r>
-              <a:rPr lang="en-GB" sz="2400" dirty="0"/>
-              <a:t>The Laugh.ogg Sound Effect used for the slime laughing can be found here: </a:t>
-            </a:r>
-            <a:r>
-              <a:rPr lang="en-GB" sz="2400" u="sng" dirty="0">
-                <a:hlinkClick r:id="rId2"/>
-              </a:rPr>
-              <a:t>https://opengameart.org/content/tiny-creatures-sounds</a:t>
-            </a:r>
-            <a:endParaRPr lang="en-GB" sz="2400" dirty="0"/>
-          </a:p>
-          <a:p>
-            <a:endParaRPr lang="en-GB" dirty="0"/>
-          </a:p>
-        </p:txBody>
-      </p:sp>
+              <a:t>Hand-MADE Sounds</a:t>
+            </a:r>
+          </a:p>
+        </p:txBody>
+      </p:sp>
+      <p:graphicFrame>
+        <p:nvGraphicFramePr>
+          <p:cNvPr id="3" name="Table 2">
+            <a:extLst>
+              <a:ext uri="{FF2B5EF4-FFF2-40B4-BE49-F238E27FC236}">
+                <a16:creationId xmlns:a16="http://schemas.microsoft.com/office/drawing/2014/main" id="{C8D99F40-09B5-1ABF-60F3-D26EF71F028B}"/>
+              </a:ext>
+            </a:extLst>
+          </p:cNvPr>
+          <p:cNvGraphicFramePr>
+            <a:graphicFrameLocks noGrp="1"/>
+          </p:cNvGraphicFramePr>
+          <p:nvPr>
+            <p:extLst>
+              <p:ext uri="{D42A27DB-BD31-4B8C-83A1-F6EECF244321}">
+                <p14:modId xmlns:p14="http://schemas.microsoft.com/office/powerpoint/2010/main" val="1456608312"/>
+              </p:ext>
+            </p:extLst>
+          </p:nvPr>
+        </p:nvGraphicFramePr>
+        <p:xfrm>
+          <a:off x="540191" y="1398719"/>
+          <a:ext cx="5300772" cy="5345739"/>
+        </p:xfrm>
+        <a:graphic>
+          <a:graphicData uri="http://schemas.openxmlformats.org/drawingml/2006/table">
+            <a:tbl>
+              <a:tblPr firstRow="1" bandRow="1">
+                <a:tableStyleId>{7DF18680-E054-41AD-8BC1-D1AEF772440D}</a:tableStyleId>
+              </a:tblPr>
+              <a:tblGrid>
+                <a:gridCol w="2629106">
+                  <a:extLst>
+                    <a:ext uri="{9D8B030D-6E8A-4147-A177-3AD203B41FA5}">
+                      <a16:colId xmlns:a16="http://schemas.microsoft.com/office/drawing/2014/main" val="181970994"/>
+                    </a:ext>
+                  </a:extLst>
+                </a:gridCol>
+                <a:gridCol w="2671666">
+                  <a:extLst>
+                    <a:ext uri="{9D8B030D-6E8A-4147-A177-3AD203B41FA5}">
+                      <a16:colId xmlns:a16="http://schemas.microsoft.com/office/drawing/2014/main" val="628041768"/>
+                    </a:ext>
+                  </a:extLst>
+                </a:gridCol>
+              </a:tblGrid>
+              <a:tr h="630181">
+                <a:tc>
+                  <a:txBody>
+                    <a:bodyPr/>
+                    <a:lstStyle/>
+                    <a:p>
+                      <a:r>
+                        <a:rPr lang="en-GB" dirty="0"/>
+                        <a:t>File Name</a:t>
+                      </a:r>
+                    </a:p>
+                  </a:txBody>
+                  <a:tcPr/>
+                </a:tc>
+                <a:tc>
+                  <a:txBody>
+                    <a:bodyPr/>
+                    <a:lstStyle/>
+                    <a:p>
+                      <a:r>
+                        <a:rPr lang="en-GB" dirty="0"/>
+                        <a:t>How sound was created</a:t>
+                      </a:r>
+                    </a:p>
+                  </a:txBody>
+                  <a:tcPr/>
+                </a:tc>
+                <a:extLst>
+                  <a:ext uri="{0D108BD9-81ED-4DB2-BD59-A6C34878D82A}">
+                    <a16:rowId xmlns:a16="http://schemas.microsoft.com/office/drawing/2014/main" val="1037850769"/>
+                  </a:ext>
+                </a:extLst>
+              </a:tr>
+              <a:tr h="672237">
+                <a:tc>
+                  <a:txBody>
+                    <a:bodyPr/>
+                    <a:lstStyle/>
+                    <a:p>
+                      <a:r>
+                        <a:rPr lang="en-GB" dirty="0"/>
+                        <a:t>Penclick.mp3</a:t>
+                      </a:r>
+                    </a:p>
+                  </a:txBody>
+                  <a:tcPr/>
+                </a:tc>
+                <a:tc>
+                  <a:txBody>
+                    <a:bodyPr/>
+                    <a:lstStyle/>
+                    <a:p>
+                      <a:r>
+                        <a:rPr lang="en-GB" dirty="0"/>
+                        <a:t>By pressing the button on a retractable pen</a:t>
+                      </a:r>
+                    </a:p>
+                  </a:txBody>
+                  <a:tcPr/>
+                </a:tc>
+                <a:extLst>
+                  <a:ext uri="{0D108BD9-81ED-4DB2-BD59-A6C34878D82A}">
+                    <a16:rowId xmlns:a16="http://schemas.microsoft.com/office/drawing/2014/main" val="1982520596"/>
+                  </a:ext>
+                </a:extLst>
+              </a:tr>
+              <a:tr h="672237">
+                <a:tc>
+                  <a:txBody>
+                    <a:bodyPr/>
+                    <a:lstStyle/>
+                    <a:p>
+                      <a:r>
+                        <a:rPr lang="en-GB" dirty="0"/>
+                        <a:t>Gravel.m4a</a:t>
+                      </a:r>
+                    </a:p>
+                  </a:txBody>
+                  <a:tcPr/>
+                </a:tc>
+                <a:tc>
+                  <a:txBody>
+                    <a:bodyPr/>
+                    <a:lstStyle/>
+                    <a:p>
+                      <a:r>
+                        <a:rPr lang="en-GB" dirty="0"/>
+                        <a:t>By walking on loose shingle </a:t>
+                      </a:r>
+                    </a:p>
+                  </a:txBody>
+                  <a:tcPr/>
+                </a:tc>
+                <a:extLst>
+                  <a:ext uri="{0D108BD9-81ED-4DB2-BD59-A6C34878D82A}">
+                    <a16:rowId xmlns:a16="http://schemas.microsoft.com/office/drawing/2014/main" val="1544250371"/>
+                  </a:ext>
+                </a:extLst>
+              </a:tr>
+              <a:tr h="672237">
+                <a:tc>
+                  <a:txBody>
+                    <a:bodyPr/>
+                    <a:lstStyle/>
+                    <a:p>
+                      <a:r>
+                        <a:rPr lang="en-GB" dirty="0"/>
+                        <a:t>Thump.m4a</a:t>
+                      </a:r>
+                    </a:p>
+                  </a:txBody>
+                  <a:tcPr/>
+                </a:tc>
+                <a:tc>
+                  <a:txBody>
+                    <a:bodyPr/>
+                    <a:lstStyle/>
+                    <a:p>
+                      <a:r>
+                        <a:rPr lang="en-GB" dirty="0"/>
+                        <a:t>Banging on the underside of a table</a:t>
+                      </a:r>
+                    </a:p>
+                  </a:txBody>
+                  <a:tcPr/>
+                </a:tc>
+                <a:extLst>
+                  <a:ext uri="{0D108BD9-81ED-4DB2-BD59-A6C34878D82A}">
+                    <a16:rowId xmlns:a16="http://schemas.microsoft.com/office/drawing/2014/main" val="336221061"/>
+                  </a:ext>
+                </a:extLst>
+              </a:tr>
+              <a:tr h="672237">
+                <a:tc>
+                  <a:txBody>
+                    <a:bodyPr/>
+                    <a:lstStyle/>
+                    <a:p>
+                      <a:r>
+                        <a:rPr lang="en-GB" dirty="0"/>
+                        <a:t>GrassWalk.m4a</a:t>
+                      </a:r>
+                    </a:p>
+                  </a:txBody>
+                  <a:tcPr/>
+                </a:tc>
+                <a:tc>
+                  <a:txBody>
+                    <a:bodyPr/>
+                    <a:lstStyle/>
+                    <a:p>
+                      <a:r>
+                        <a:rPr lang="en-GB" dirty="0"/>
+                        <a:t>By walking on long grass</a:t>
+                      </a:r>
+                    </a:p>
+                  </a:txBody>
+                  <a:tcPr/>
+                </a:tc>
+                <a:extLst>
+                  <a:ext uri="{0D108BD9-81ED-4DB2-BD59-A6C34878D82A}">
+                    <a16:rowId xmlns:a16="http://schemas.microsoft.com/office/drawing/2014/main" val="2088809235"/>
+                  </a:ext>
+                </a:extLst>
+              </a:tr>
+              <a:tr h="672237">
+                <a:tc>
+                  <a:txBody>
+                    <a:bodyPr/>
+                    <a:lstStyle/>
+                    <a:p>
+                      <a:r>
+                        <a:rPr lang="en-GB" dirty="0"/>
+                        <a:t>ConcreteWalk.m4a</a:t>
+                      </a:r>
+                    </a:p>
+                  </a:txBody>
+                  <a:tcPr/>
+                </a:tc>
+                <a:tc>
+                  <a:txBody>
+                    <a:bodyPr/>
+                    <a:lstStyle/>
+                    <a:p>
+                      <a:r>
+                        <a:rPr lang="en-GB" dirty="0"/>
+                        <a:t>By walking on garden paving slabs</a:t>
+                      </a:r>
+                    </a:p>
+                  </a:txBody>
+                  <a:tcPr/>
+                </a:tc>
+                <a:extLst>
+                  <a:ext uri="{0D108BD9-81ED-4DB2-BD59-A6C34878D82A}">
+                    <a16:rowId xmlns:a16="http://schemas.microsoft.com/office/drawing/2014/main" val="3040528228"/>
+                  </a:ext>
+                </a:extLst>
+              </a:tr>
+              <a:tr h="672237">
+                <a:tc>
+                  <a:txBody>
+                    <a:bodyPr/>
+                    <a:lstStyle/>
+                    <a:p>
+                      <a:r>
+                        <a:rPr lang="en-GB" dirty="0"/>
+                        <a:t>CoinPickUp.m4a</a:t>
+                      </a:r>
+                    </a:p>
+                  </a:txBody>
+                  <a:tcPr/>
+                </a:tc>
+                <a:tc>
+                  <a:txBody>
+                    <a:bodyPr/>
+                    <a:lstStyle/>
+                    <a:p>
+                      <a:r>
+                        <a:rPr lang="en-GB" dirty="0"/>
+                        <a:t>Flicking the upper part of a glass </a:t>
+                      </a:r>
+                    </a:p>
+                  </a:txBody>
+                  <a:tcPr/>
+                </a:tc>
+                <a:extLst>
+                  <a:ext uri="{0D108BD9-81ED-4DB2-BD59-A6C34878D82A}">
+                    <a16:rowId xmlns:a16="http://schemas.microsoft.com/office/drawing/2014/main" val="305773528"/>
+                  </a:ext>
+                </a:extLst>
+              </a:tr>
+              <a:tr h="672237">
+                <a:tc>
+                  <a:txBody>
+                    <a:bodyPr/>
+                    <a:lstStyle/>
+                    <a:p>
+                      <a:r>
+                        <a:rPr lang="en-GB" dirty="0"/>
+                        <a:t>Snaps2.m4a</a:t>
+                      </a:r>
+                    </a:p>
+                  </a:txBody>
+                  <a:tcPr/>
+                </a:tc>
+                <a:tc>
+                  <a:txBody>
+                    <a:bodyPr/>
+                    <a:lstStyle/>
+                    <a:p>
+                      <a:r>
+                        <a:rPr lang="en-GB" dirty="0"/>
+                        <a:t>Stepping on shed eucalyptus bark </a:t>
+                      </a:r>
+                    </a:p>
+                  </a:txBody>
+                  <a:tcPr/>
+                </a:tc>
+                <a:extLst>
+                  <a:ext uri="{0D108BD9-81ED-4DB2-BD59-A6C34878D82A}">
+                    <a16:rowId xmlns:a16="http://schemas.microsoft.com/office/drawing/2014/main" val="1317083244"/>
+                  </a:ext>
+                </a:extLst>
+              </a:tr>
+            </a:tbl>
+          </a:graphicData>
+        </a:graphic>
+      </p:graphicFrame>
+      <p:graphicFrame>
+        <p:nvGraphicFramePr>
+          <p:cNvPr id="4" name="Table 3">
+            <a:extLst>
+              <a:ext uri="{FF2B5EF4-FFF2-40B4-BE49-F238E27FC236}">
+                <a16:creationId xmlns:a16="http://schemas.microsoft.com/office/drawing/2014/main" id="{393C45D4-BFD8-41B4-B981-0F6CE0CDFA7D}"/>
+              </a:ext>
+            </a:extLst>
+          </p:cNvPr>
+          <p:cNvGraphicFramePr>
+            <a:graphicFrameLocks noGrp="1"/>
+          </p:cNvGraphicFramePr>
+          <p:nvPr>
+            <p:extLst>
+              <p:ext uri="{D42A27DB-BD31-4B8C-83A1-F6EECF244321}">
+                <p14:modId xmlns:p14="http://schemas.microsoft.com/office/powerpoint/2010/main" val="1624055265"/>
+              </p:ext>
+            </p:extLst>
+          </p:nvPr>
+        </p:nvGraphicFramePr>
+        <p:xfrm>
+          <a:off x="6095999" y="1420077"/>
+          <a:ext cx="5781870" cy="4946245"/>
+        </p:xfrm>
+        <a:graphic>
+          <a:graphicData uri="http://schemas.openxmlformats.org/drawingml/2006/table">
+            <a:tbl>
+              <a:tblPr firstRow="1" bandRow="1">
+                <a:tableStyleId>{7DF18680-E054-41AD-8BC1-D1AEF772440D}</a:tableStyleId>
+              </a:tblPr>
+              <a:tblGrid>
+                <a:gridCol w="2890935">
+                  <a:extLst>
+                    <a:ext uri="{9D8B030D-6E8A-4147-A177-3AD203B41FA5}">
+                      <a16:colId xmlns:a16="http://schemas.microsoft.com/office/drawing/2014/main" val="181970994"/>
+                    </a:ext>
+                  </a:extLst>
+                </a:gridCol>
+                <a:gridCol w="2890935">
+                  <a:extLst>
+                    <a:ext uri="{9D8B030D-6E8A-4147-A177-3AD203B41FA5}">
+                      <a16:colId xmlns:a16="http://schemas.microsoft.com/office/drawing/2014/main" val="628041768"/>
+                    </a:ext>
+                  </a:extLst>
+                </a:gridCol>
+              </a:tblGrid>
+              <a:tr h="386493">
+                <a:tc>
+                  <a:txBody>
+                    <a:bodyPr/>
+                    <a:lstStyle/>
+                    <a:p>
+                      <a:r>
+                        <a:rPr lang="en-GB" dirty="0"/>
+                        <a:t>File Name</a:t>
+                      </a:r>
+                    </a:p>
+                  </a:txBody>
+                  <a:tcPr/>
+                </a:tc>
+                <a:tc>
+                  <a:txBody>
+                    <a:bodyPr/>
+                    <a:lstStyle/>
+                    <a:p>
+                      <a:r>
+                        <a:rPr lang="en-GB" dirty="0"/>
+                        <a:t>How sound was created</a:t>
+                      </a:r>
+                    </a:p>
+                  </a:txBody>
+                  <a:tcPr/>
+                </a:tc>
+                <a:extLst>
+                  <a:ext uri="{0D108BD9-81ED-4DB2-BD59-A6C34878D82A}">
+                    <a16:rowId xmlns:a16="http://schemas.microsoft.com/office/drawing/2014/main" val="1037850769"/>
+                  </a:ext>
+                </a:extLst>
+              </a:tr>
+              <a:tr h="759348">
+                <a:tc>
+                  <a:txBody>
+                    <a:bodyPr/>
+                    <a:lstStyle/>
+                    <a:p>
+                      <a:r>
+                        <a:rPr lang="en-GB" dirty="0"/>
+                        <a:t>BellChime.mp3</a:t>
+                      </a:r>
+                    </a:p>
+                  </a:txBody>
+                  <a:tcPr/>
+                </a:tc>
+                <a:tc>
+                  <a:txBody>
+                    <a:bodyPr/>
+                    <a:lstStyle/>
+                    <a:p>
+                      <a:r>
+                        <a:rPr lang="en-GB" dirty="0"/>
+                        <a:t>Gently ringing an old garden bell</a:t>
+                      </a:r>
+                    </a:p>
+                  </a:txBody>
+                  <a:tcPr/>
+                </a:tc>
+                <a:extLst>
+                  <a:ext uri="{0D108BD9-81ED-4DB2-BD59-A6C34878D82A}">
+                    <a16:rowId xmlns:a16="http://schemas.microsoft.com/office/drawing/2014/main" val="1982520596"/>
+                  </a:ext>
+                </a:extLst>
+              </a:tr>
+              <a:tr h="721501">
+                <a:tc>
+                  <a:txBody>
+                    <a:bodyPr/>
+                    <a:lstStyle/>
+                    <a:p>
+                      <a:r>
+                        <a:rPr lang="en-GB" dirty="0"/>
+                        <a:t>Keys.mp3</a:t>
+                      </a:r>
+                    </a:p>
+                  </a:txBody>
+                  <a:tcPr/>
+                </a:tc>
+                <a:tc>
+                  <a:txBody>
+                    <a:bodyPr/>
+                    <a:lstStyle/>
+                    <a:p>
+                      <a:r>
+                        <a:rPr lang="en-GB" dirty="0"/>
+                        <a:t>Gently shaking a keychain of keys together</a:t>
+                      </a:r>
+                    </a:p>
+                  </a:txBody>
+                  <a:tcPr/>
+                </a:tc>
+                <a:extLst>
+                  <a:ext uri="{0D108BD9-81ED-4DB2-BD59-A6C34878D82A}">
+                    <a16:rowId xmlns:a16="http://schemas.microsoft.com/office/drawing/2014/main" val="1544250371"/>
+                  </a:ext>
+                </a:extLst>
+              </a:tr>
+              <a:tr h="721501">
+                <a:tc>
+                  <a:txBody>
+                    <a:bodyPr/>
+                    <a:lstStyle/>
+                    <a:p>
+                      <a:r>
+                        <a:rPr lang="en-GB" dirty="0"/>
+                        <a:t>Flannel.m4a</a:t>
+                      </a:r>
+                    </a:p>
+                  </a:txBody>
+                  <a:tcPr/>
+                </a:tc>
+                <a:tc>
+                  <a:txBody>
+                    <a:bodyPr/>
+                    <a:lstStyle/>
+                    <a:p>
+                      <a:r>
+                        <a:rPr lang="en-GB" dirty="0"/>
+                        <a:t>Rinsing a wet flannel and squeezing it repeatedly</a:t>
+                      </a:r>
+                    </a:p>
+                  </a:txBody>
+                  <a:tcPr/>
+                </a:tc>
+                <a:extLst>
+                  <a:ext uri="{0D108BD9-81ED-4DB2-BD59-A6C34878D82A}">
+                    <a16:rowId xmlns:a16="http://schemas.microsoft.com/office/drawing/2014/main" val="336221061"/>
+                  </a:ext>
+                </a:extLst>
+              </a:tr>
+              <a:tr h="721501">
+                <a:tc>
+                  <a:txBody>
+                    <a:bodyPr/>
+                    <a:lstStyle/>
+                    <a:p>
+                      <a:r>
+                        <a:rPr lang="en-GB" dirty="0"/>
+                        <a:t>Water.m4a</a:t>
+                      </a:r>
+                    </a:p>
+                  </a:txBody>
+                  <a:tcPr/>
+                </a:tc>
+                <a:tc>
+                  <a:txBody>
+                    <a:bodyPr/>
+                    <a:lstStyle/>
+                    <a:p>
+                      <a:r>
+                        <a:rPr lang="en-GB" dirty="0"/>
+                        <a:t>Breaking surface tension of water using fingers</a:t>
+                      </a:r>
+                    </a:p>
+                  </a:txBody>
+                  <a:tcPr/>
+                </a:tc>
+                <a:extLst>
+                  <a:ext uri="{0D108BD9-81ED-4DB2-BD59-A6C34878D82A}">
+                    <a16:rowId xmlns:a16="http://schemas.microsoft.com/office/drawing/2014/main" val="2088809235"/>
+                  </a:ext>
+                </a:extLst>
+              </a:tr>
+              <a:tr h="721501">
+                <a:tc>
+                  <a:txBody>
+                    <a:bodyPr/>
+                    <a:lstStyle/>
+                    <a:p>
+                      <a:r>
+                        <a:rPr lang="en-GB" dirty="0"/>
+                        <a:t>Leaves1.m4a</a:t>
+                      </a:r>
+                    </a:p>
+                  </a:txBody>
+                  <a:tcPr/>
+                </a:tc>
+                <a:tc>
+                  <a:txBody>
+                    <a:bodyPr/>
+                    <a:lstStyle/>
+                    <a:p>
+                      <a:r>
+                        <a:rPr lang="en-GB" dirty="0"/>
+                        <a:t>Gently shaking a bush in the wind. Includes bird’s tweets as background noise</a:t>
+                      </a:r>
+                    </a:p>
+                  </a:txBody>
+                  <a:tcPr/>
+                </a:tc>
+                <a:extLst>
+                  <a:ext uri="{0D108BD9-81ED-4DB2-BD59-A6C34878D82A}">
+                    <a16:rowId xmlns:a16="http://schemas.microsoft.com/office/drawing/2014/main" val="3040528228"/>
+                  </a:ext>
+                </a:extLst>
+              </a:tr>
+              <a:tr h="721501">
+                <a:tc>
+                  <a:txBody>
+                    <a:bodyPr/>
+                    <a:lstStyle/>
+                    <a:p>
+                      <a:r>
+                        <a:rPr lang="en-GB" dirty="0"/>
+                        <a:t>WoodCreak.m4a</a:t>
+                      </a:r>
+                    </a:p>
+                  </a:txBody>
+                  <a:tcPr/>
+                </a:tc>
+                <a:tc>
+                  <a:txBody>
+                    <a:bodyPr/>
+                    <a:lstStyle/>
+                    <a:p>
+                      <a:r>
+                        <a:rPr lang="en-GB" dirty="0"/>
+                        <a:t>Shaking a pile of chopped branches together</a:t>
+                      </a:r>
+                    </a:p>
+                  </a:txBody>
+                  <a:tcPr/>
+                </a:tc>
+                <a:extLst>
+                  <a:ext uri="{0D108BD9-81ED-4DB2-BD59-A6C34878D82A}">
+                    <a16:rowId xmlns:a16="http://schemas.microsoft.com/office/drawing/2014/main" val="305773528"/>
+                  </a:ext>
+                </a:extLst>
+              </a:tr>
+            </a:tbl>
+          </a:graphicData>
+        </a:graphic>
+      </p:graphicFrame>
     </p:spTree>
     <p:extLst>
       <p:ext uri="{BB962C8B-B14F-4D97-AF65-F5344CB8AC3E}">
-        <p14:creationId xmlns:p14="http://schemas.microsoft.com/office/powerpoint/2010/main" val="984374411"/>
+        <p14:creationId xmlns:p14="http://schemas.microsoft.com/office/powerpoint/2010/main" val="3032562648"/>
       </p:ext>
     </p:extLst>
   </p:cSld>
@@ -8896,6 +9450,12 @@
             <a:r>
               <a:rPr lang="en-GB" sz="2400" dirty="0"/>
               <a:t>Original sound was a Pen Click</a:t>
+            </a:r>
+          </a:p>
+          <a:p>
+            <a:r>
+              <a:rPr lang="en-GB" sz="2400" dirty="0"/>
+              <a:t>Amplified by 11.1dB</a:t>
             </a:r>
           </a:p>
           <a:p>
@@ -8972,13 +9532,7 @@
   <p:cSld>
     <p:spTree>
       <p:nvGrpSpPr>
-        <p:cNvPr id="1" name="">
-          <a:extLst>
-            <a:ext uri="{FF2B5EF4-FFF2-40B4-BE49-F238E27FC236}">
-              <a16:creationId xmlns:a16="http://schemas.microsoft.com/office/drawing/2014/main" id="{7C03BD2E-B010-879D-7CDC-F403EDB89F5B}"/>
-            </a:ext>
-          </a:extLst>
-        </p:cNvPr>
+        <p:cNvPr id="1" name=""/>
         <p:cNvGrpSpPr/>
         <p:nvPr/>
       </p:nvGrpSpPr>
@@ -8995,7 +9549,7 @@
           <p:cNvPr id="2" name="Title 1">
             <a:extLst>
               <a:ext uri="{FF2B5EF4-FFF2-40B4-BE49-F238E27FC236}">
-                <a16:creationId xmlns:a16="http://schemas.microsoft.com/office/drawing/2014/main" id="{A22BAA2A-442E-3E81-F11C-F674141CAC4E}"/>
+                <a16:creationId xmlns:a16="http://schemas.microsoft.com/office/drawing/2014/main" id="{4A669AEC-2DF0-2255-F587-D88A4590DD2B}"/>
               </a:ext>
             </a:extLst>
           </p:cNvPr>
@@ -9018,505 +9572,70 @@
           <a:p>
             <a:r>
               <a:rPr lang="en-GB" dirty="0"/>
-              <a:t>Hand-MADE Sounds</a:t>
-            </a:r>
-          </a:p>
-        </p:txBody>
-      </p:sp>
-      <p:graphicFrame>
-        <p:nvGraphicFramePr>
-          <p:cNvPr id="3" name="Table 2">
-            <a:extLst>
-              <a:ext uri="{FF2B5EF4-FFF2-40B4-BE49-F238E27FC236}">
-                <a16:creationId xmlns:a16="http://schemas.microsoft.com/office/drawing/2014/main" id="{C8D99F40-09B5-1ABF-60F3-D26EF71F028B}"/>
-              </a:ext>
-            </a:extLst>
-          </p:cNvPr>
-          <p:cNvGraphicFramePr>
-            <a:graphicFrameLocks noGrp="1"/>
-          </p:cNvGraphicFramePr>
-          <p:nvPr>
-            <p:extLst>
-              <p:ext uri="{D42A27DB-BD31-4B8C-83A1-F6EECF244321}">
-                <p14:modId xmlns:p14="http://schemas.microsoft.com/office/powerpoint/2010/main" val="3219516698"/>
-              </p:ext>
-            </p:extLst>
-          </p:nvPr>
-        </p:nvGraphicFramePr>
-        <p:xfrm>
-          <a:off x="540191" y="1398719"/>
-          <a:ext cx="5429062" cy="4481590"/>
-        </p:xfrm>
-        <a:graphic>
-          <a:graphicData uri="http://schemas.openxmlformats.org/drawingml/2006/table">
-            <a:tbl>
-              <a:tblPr firstRow="1" bandRow="1">
-                <a:tableStyleId>{7DF18680-E054-41AD-8BC1-D1AEF772440D}</a:tableStyleId>
-              </a:tblPr>
-              <a:tblGrid>
-                <a:gridCol w="2692736">
-                  <a:extLst>
-                    <a:ext uri="{9D8B030D-6E8A-4147-A177-3AD203B41FA5}">
-                      <a16:colId xmlns:a16="http://schemas.microsoft.com/office/drawing/2014/main" val="181970994"/>
-                    </a:ext>
-                  </a:extLst>
-                </a:gridCol>
-                <a:gridCol w="2736326">
-                  <a:extLst>
-                    <a:ext uri="{9D8B030D-6E8A-4147-A177-3AD203B41FA5}">
-                      <a16:colId xmlns:a16="http://schemas.microsoft.com/office/drawing/2014/main" val="628041768"/>
-                    </a:ext>
-                  </a:extLst>
-                </a:gridCol>
-              </a:tblGrid>
-              <a:tr h="384814">
-                <a:tc>
-                  <a:txBody>
-                    <a:bodyPr/>
-                    <a:lstStyle/>
-                    <a:p>
-                      <a:r>
-                        <a:rPr lang="en-GB" dirty="0"/>
-                        <a:t>File Name</a:t>
-                      </a:r>
-                    </a:p>
-                  </a:txBody>
-                  <a:tcPr/>
-                </a:tc>
-                <a:tc>
-                  <a:txBody>
-                    <a:bodyPr/>
-                    <a:lstStyle/>
-                    <a:p>
-                      <a:r>
-                        <a:rPr lang="en-GB" dirty="0"/>
-                        <a:t>How sound was created</a:t>
-                      </a:r>
-                    </a:p>
-                  </a:txBody>
-                  <a:tcPr/>
-                </a:tc>
-                <a:extLst>
-                  <a:ext uri="{0D108BD9-81ED-4DB2-BD59-A6C34878D82A}">
-                    <a16:rowId xmlns:a16="http://schemas.microsoft.com/office/drawing/2014/main" val="1037850769"/>
-                  </a:ext>
-                </a:extLst>
-              </a:tr>
-              <a:tr h="682796">
-                <a:tc>
-                  <a:txBody>
-                    <a:bodyPr/>
-                    <a:lstStyle/>
-                    <a:p>
-                      <a:endParaRPr lang="en-GB" dirty="0"/>
-                    </a:p>
-                  </a:txBody>
-                  <a:tcPr/>
-                </a:tc>
-                <a:tc>
-                  <a:txBody>
-                    <a:bodyPr/>
-                    <a:lstStyle/>
-                    <a:p>
-                      <a:endParaRPr lang="en-GB"/>
-                    </a:p>
-                  </a:txBody>
-                  <a:tcPr/>
-                </a:tc>
-                <a:extLst>
-                  <a:ext uri="{0D108BD9-81ED-4DB2-BD59-A6C34878D82A}">
-                    <a16:rowId xmlns:a16="http://schemas.microsoft.com/office/drawing/2014/main" val="1982520596"/>
-                  </a:ext>
-                </a:extLst>
-              </a:tr>
-              <a:tr h="682796">
-                <a:tc>
-                  <a:txBody>
-                    <a:bodyPr/>
-                    <a:lstStyle/>
-                    <a:p>
-                      <a:endParaRPr lang="en-GB" dirty="0"/>
-                    </a:p>
-                  </a:txBody>
-                  <a:tcPr/>
-                </a:tc>
-                <a:tc>
-                  <a:txBody>
-                    <a:bodyPr/>
-                    <a:lstStyle/>
-                    <a:p>
-                      <a:endParaRPr lang="en-GB"/>
-                    </a:p>
-                  </a:txBody>
-                  <a:tcPr/>
-                </a:tc>
-                <a:extLst>
-                  <a:ext uri="{0D108BD9-81ED-4DB2-BD59-A6C34878D82A}">
-                    <a16:rowId xmlns:a16="http://schemas.microsoft.com/office/drawing/2014/main" val="1544250371"/>
-                  </a:ext>
-                </a:extLst>
-              </a:tr>
-              <a:tr h="682796">
-                <a:tc>
-                  <a:txBody>
-                    <a:bodyPr/>
-                    <a:lstStyle/>
-                    <a:p>
-                      <a:endParaRPr lang="en-GB"/>
-                    </a:p>
-                  </a:txBody>
-                  <a:tcPr/>
-                </a:tc>
-                <a:tc>
-                  <a:txBody>
-                    <a:bodyPr/>
-                    <a:lstStyle/>
-                    <a:p>
-                      <a:endParaRPr lang="en-GB" dirty="0"/>
-                    </a:p>
-                  </a:txBody>
-                  <a:tcPr/>
-                </a:tc>
-                <a:extLst>
-                  <a:ext uri="{0D108BD9-81ED-4DB2-BD59-A6C34878D82A}">
-                    <a16:rowId xmlns:a16="http://schemas.microsoft.com/office/drawing/2014/main" val="336221061"/>
-                  </a:ext>
-                </a:extLst>
-              </a:tr>
-              <a:tr h="682796">
-                <a:tc>
-                  <a:txBody>
-                    <a:bodyPr/>
-                    <a:lstStyle/>
-                    <a:p>
-                      <a:endParaRPr lang="en-GB"/>
-                    </a:p>
-                  </a:txBody>
-                  <a:tcPr/>
-                </a:tc>
-                <a:tc>
-                  <a:txBody>
-                    <a:bodyPr/>
-                    <a:lstStyle/>
-                    <a:p>
-                      <a:endParaRPr lang="en-GB"/>
-                    </a:p>
-                  </a:txBody>
-                  <a:tcPr/>
-                </a:tc>
-                <a:extLst>
-                  <a:ext uri="{0D108BD9-81ED-4DB2-BD59-A6C34878D82A}">
-                    <a16:rowId xmlns:a16="http://schemas.microsoft.com/office/drawing/2014/main" val="2088809235"/>
-                  </a:ext>
-                </a:extLst>
-              </a:tr>
-              <a:tr h="682796">
-                <a:tc>
-                  <a:txBody>
-                    <a:bodyPr/>
-                    <a:lstStyle/>
-                    <a:p>
-                      <a:endParaRPr lang="en-GB" dirty="0"/>
-                    </a:p>
-                  </a:txBody>
-                  <a:tcPr/>
-                </a:tc>
-                <a:tc>
-                  <a:txBody>
-                    <a:bodyPr/>
-                    <a:lstStyle/>
-                    <a:p>
-                      <a:endParaRPr lang="en-GB" dirty="0"/>
-                    </a:p>
-                  </a:txBody>
-                  <a:tcPr/>
-                </a:tc>
-                <a:extLst>
-                  <a:ext uri="{0D108BD9-81ED-4DB2-BD59-A6C34878D82A}">
-                    <a16:rowId xmlns:a16="http://schemas.microsoft.com/office/drawing/2014/main" val="3040528228"/>
-                  </a:ext>
-                </a:extLst>
-              </a:tr>
-              <a:tr h="682796">
-                <a:tc>
-                  <a:txBody>
-                    <a:bodyPr/>
-                    <a:lstStyle/>
-                    <a:p>
-                      <a:endParaRPr lang="en-GB" dirty="0"/>
-                    </a:p>
-                  </a:txBody>
-                  <a:tcPr/>
-                </a:tc>
-                <a:tc>
-                  <a:txBody>
-                    <a:bodyPr/>
-                    <a:lstStyle/>
-                    <a:p>
-                      <a:endParaRPr lang="en-GB" dirty="0"/>
-                    </a:p>
-                  </a:txBody>
-                  <a:tcPr/>
-                </a:tc>
-                <a:extLst>
-                  <a:ext uri="{0D108BD9-81ED-4DB2-BD59-A6C34878D82A}">
-                    <a16:rowId xmlns:a16="http://schemas.microsoft.com/office/drawing/2014/main" val="305773528"/>
-                  </a:ext>
-                </a:extLst>
-              </a:tr>
-            </a:tbl>
-          </a:graphicData>
-        </a:graphic>
-      </p:graphicFrame>
-      <p:graphicFrame>
-        <p:nvGraphicFramePr>
-          <p:cNvPr id="4" name="Table 3">
-            <a:extLst>
-              <a:ext uri="{FF2B5EF4-FFF2-40B4-BE49-F238E27FC236}">
-                <a16:creationId xmlns:a16="http://schemas.microsoft.com/office/drawing/2014/main" id="{393C45D4-BFD8-41B4-B981-0F6CE0CDFA7D}"/>
-              </a:ext>
-            </a:extLst>
-          </p:cNvPr>
-          <p:cNvGraphicFramePr>
-            <a:graphicFrameLocks noGrp="1"/>
-          </p:cNvGraphicFramePr>
-          <p:nvPr>
-            <p:extLst>
-              <p:ext uri="{D42A27DB-BD31-4B8C-83A1-F6EECF244321}">
-                <p14:modId xmlns:p14="http://schemas.microsoft.com/office/powerpoint/2010/main" val="2694835298"/>
-              </p:ext>
-            </p:extLst>
-          </p:nvPr>
-        </p:nvGraphicFramePr>
-        <p:xfrm>
-          <a:off x="6095999" y="1420077"/>
-          <a:ext cx="5429062" cy="4462536"/>
-        </p:xfrm>
-        <a:graphic>
-          <a:graphicData uri="http://schemas.openxmlformats.org/drawingml/2006/table">
-            <a:tbl>
-              <a:tblPr firstRow="1" bandRow="1">
-                <a:tableStyleId>{7DF18680-E054-41AD-8BC1-D1AEF772440D}</a:tableStyleId>
-              </a:tblPr>
-              <a:tblGrid>
-                <a:gridCol w="2714531">
-                  <a:extLst>
-                    <a:ext uri="{9D8B030D-6E8A-4147-A177-3AD203B41FA5}">
-                      <a16:colId xmlns:a16="http://schemas.microsoft.com/office/drawing/2014/main" val="181970994"/>
-                    </a:ext>
-                  </a:extLst>
-                </a:gridCol>
-                <a:gridCol w="2714531">
-                  <a:extLst>
-                    <a:ext uri="{9D8B030D-6E8A-4147-A177-3AD203B41FA5}">
-                      <a16:colId xmlns:a16="http://schemas.microsoft.com/office/drawing/2014/main" val="628041768"/>
-                    </a:ext>
-                  </a:extLst>
-                </a:gridCol>
-              </a:tblGrid>
-              <a:tr h="160671">
-                <a:tc>
-                  <a:txBody>
-                    <a:bodyPr/>
-                    <a:lstStyle/>
-                    <a:p>
-                      <a:r>
-                        <a:rPr lang="en-GB" dirty="0"/>
-                        <a:t>File Name</a:t>
-                      </a:r>
-                    </a:p>
-                  </a:txBody>
-                  <a:tcPr/>
-                </a:tc>
-                <a:tc>
-                  <a:txBody>
-                    <a:bodyPr/>
-                    <a:lstStyle/>
-                    <a:p>
-                      <a:r>
-                        <a:rPr lang="en-GB" dirty="0"/>
-                        <a:t>How sound was created</a:t>
-                      </a:r>
-                    </a:p>
-                  </a:txBody>
-                  <a:tcPr/>
-                </a:tc>
-                <a:extLst>
-                  <a:ext uri="{0D108BD9-81ED-4DB2-BD59-A6C34878D82A}">
-                    <a16:rowId xmlns:a16="http://schemas.microsoft.com/office/drawing/2014/main" val="1037850769"/>
-                  </a:ext>
-                </a:extLst>
-              </a:tr>
-              <a:tr h="682796">
-                <a:tc>
-                  <a:txBody>
-                    <a:bodyPr/>
-                    <a:lstStyle/>
-                    <a:p>
-                      <a:endParaRPr lang="en-GB" dirty="0"/>
-                    </a:p>
-                  </a:txBody>
-                  <a:tcPr/>
-                </a:tc>
-                <a:tc>
-                  <a:txBody>
-                    <a:bodyPr/>
-                    <a:lstStyle/>
-                    <a:p>
-                      <a:endParaRPr lang="en-GB" dirty="0"/>
-                    </a:p>
-                  </a:txBody>
-                  <a:tcPr/>
-                </a:tc>
-                <a:extLst>
-                  <a:ext uri="{0D108BD9-81ED-4DB2-BD59-A6C34878D82A}">
-                    <a16:rowId xmlns:a16="http://schemas.microsoft.com/office/drawing/2014/main" val="1982520596"/>
-                  </a:ext>
-                </a:extLst>
-              </a:tr>
-              <a:tr h="682796">
-                <a:tc>
-                  <a:txBody>
-                    <a:bodyPr/>
-                    <a:lstStyle/>
-                    <a:p>
-                      <a:endParaRPr lang="en-GB"/>
-                    </a:p>
-                  </a:txBody>
-                  <a:tcPr/>
-                </a:tc>
-                <a:tc>
-                  <a:txBody>
-                    <a:bodyPr/>
-                    <a:lstStyle/>
-                    <a:p>
-                      <a:endParaRPr lang="en-GB"/>
-                    </a:p>
-                  </a:txBody>
-                  <a:tcPr/>
-                </a:tc>
-                <a:extLst>
-                  <a:ext uri="{0D108BD9-81ED-4DB2-BD59-A6C34878D82A}">
-                    <a16:rowId xmlns:a16="http://schemas.microsoft.com/office/drawing/2014/main" val="1544250371"/>
-                  </a:ext>
-                </a:extLst>
-              </a:tr>
-              <a:tr h="682796">
-                <a:tc>
-                  <a:txBody>
-                    <a:bodyPr/>
-                    <a:lstStyle/>
-                    <a:p>
-                      <a:endParaRPr lang="en-GB" dirty="0"/>
-                    </a:p>
-                  </a:txBody>
-                  <a:tcPr/>
-                </a:tc>
-                <a:tc>
-                  <a:txBody>
-                    <a:bodyPr/>
-                    <a:lstStyle/>
-                    <a:p>
-                      <a:endParaRPr lang="en-GB" dirty="0"/>
-                    </a:p>
-                  </a:txBody>
-                  <a:tcPr/>
-                </a:tc>
-                <a:extLst>
-                  <a:ext uri="{0D108BD9-81ED-4DB2-BD59-A6C34878D82A}">
-                    <a16:rowId xmlns:a16="http://schemas.microsoft.com/office/drawing/2014/main" val="336221061"/>
-                  </a:ext>
-                </a:extLst>
-              </a:tr>
-              <a:tr h="682796">
-                <a:tc>
-                  <a:txBody>
-                    <a:bodyPr/>
-                    <a:lstStyle/>
-                    <a:p>
-                      <a:endParaRPr lang="en-GB"/>
-                    </a:p>
-                  </a:txBody>
-                  <a:tcPr/>
-                </a:tc>
-                <a:tc>
-                  <a:txBody>
-                    <a:bodyPr/>
-                    <a:lstStyle/>
-                    <a:p>
-                      <a:endParaRPr lang="en-GB"/>
-                    </a:p>
-                  </a:txBody>
-                  <a:tcPr/>
-                </a:tc>
-                <a:extLst>
-                  <a:ext uri="{0D108BD9-81ED-4DB2-BD59-A6C34878D82A}">
-                    <a16:rowId xmlns:a16="http://schemas.microsoft.com/office/drawing/2014/main" val="2088809235"/>
-                  </a:ext>
-                </a:extLst>
-              </a:tr>
-              <a:tr h="682796">
-                <a:tc>
-                  <a:txBody>
-                    <a:bodyPr/>
-                    <a:lstStyle/>
-                    <a:p>
-                      <a:endParaRPr lang="en-GB" dirty="0"/>
-                    </a:p>
-                  </a:txBody>
-                  <a:tcPr/>
-                </a:tc>
-                <a:tc>
-                  <a:txBody>
-                    <a:bodyPr/>
-                    <a:lstStyle/>
-                    <a:p>
-                      <a:endParaRPr lang="en-GB" dirty="0"/>
-                    </a:p>
-                  </a:txBody>
-                  <a:tcPr/>
-                </a:tc>
-                <a:extLst>
-                  <a:ext uri="{0D108BD9-81ED-4DB2-BD59-A6C34878D82A}">
-                    <a16:rowId xmlns:a16="http://schemas.microsoft.com/office/drawing/2014/main" val="3040528228"/>
-                  </a:ext>
-                </a:extLst>
-              </a:tr>
-              <a:tr h="682796">
-                <a:tc>
-                  <a:txBody>
-                    <a:bodyPr/>
-                    <a:lstStyle/>
-                    <a:p>
-                      <a:endParaRPr lang="en-GB" dirty="0"/>
-                    </a:p>
-                  </a:txBody>
-                  <a:tcPr/>
-                </a:tc>
-                <a:tc>
-                  <a:txBody>
-                    <a:bodyPr/>
-                    <a:lstStyle/>
-                    <a:p>
-                      <a:endParaRPr lang="en-GB" dirty="0"/>
-                    </a:p>
-                  </a:txBody>
-                  <a:tcPr/>
-                </a:tc>
-                <a:extLst>
-                  <a:ext uri="{0D108BD9-81ED-4DB2-BD59-A6C34878D82A}">
-                    <a16:rowId xmlns:a16="http://schemas.microsoft.com/office/drawing/2014/main" val="305773528"/>
-                  </a:ext>
-                </a:extLst>
-              </a:tr>
-            </a:tbl>
-          </a:graphicData>
-        </a:graphic>
-      </p:graphicFrame>
+              <a:t>Sound ORIGINS</a:t>
+            </a:r>
+          </a:p>
+        </p:txBody>
+      </p:sp>
+      <p:sp>
+        <p:nvSpPr>
+          <p:cNvPr id="3" name="Content Placeholder 2">
+            <a:extLst>
+              <a:ext uri="{FF2B5EF4-FFF2-40B4-BE49-F238E27FC236}">
+                <a16:creationId xmlns:a16="http://schemas.microsoft.com/office/drawing/2014/main" id="{077BADC9-E785-AB9C-2915-D6DE1879AC85}"/>
+              </a:ext>
+            </a:extLst>
+          </p:cNvPr>
+          <p:cNvSpPr>
+            <a:spLocks noGrp="1"/>
+          </p:cNvSpPr>
+          <p:nvPr>
+            <p:ph idx="1"/>
+          </p:nvPr>
+        </p:nvSpPr>
+        <p:spPr>
+          <a:xfrm>
+            <a:off x="2093976" y="1405771"/>
+            <a:ext cx="7729728" cy="3101983"/>
+          </a:xfrm>
+        </p:spPr>
+        <p:txBody>
+          <a:bodyPr/>
+          <a:lstStyle/>
+          <a:p>
+            <a:r>
+              <a:rPr lang="en-GB" sz="2400" dirty="0"/>
+              <a:t>Most sounds were recorded by me and are listed on the Recording Details Template</a:t>
+            </a:r>
+          </a:p>
+          <a:p>
+            <a:pPr marL="0" indent="0">
+              <a:buNone/>
+            </a:pPr>
+            <a:endParaRPr lang="en-GB" sz="2400" dirty="0"/>
+          </a:p>
+          <a:p>
+            <a:r>
+              <a:rPr lang="en-GB" sz="2400" dirty="0"/>
+              <a:t>The Laugh.ogg Sound Effect used for the slime laughing can be found here: </a:t>
+            </a:r>
+            <a:r>
+              <a:rPr lang="en-GB" sz="2400" u="sng" dirty="0">
+                <a:hlinkClick r:id="rId2"/>
+              </a:rPr>
+              <a:t>https://opengameart.org/content/tiny-creatures-sounds</a:t>
+            </a:r>
+            <a:endParaRPr lang="en-GB" sz="2400" dirty="0"/>
+          </a:p>
+          <a:p>
+            <a:endParaRPr lang="en-GB" dirty="0"/>
+          </a:p>
+        </p:txBody>
+      </p:sp>
     </p:spTree>
     <p:extLst>
       <p:ext uri="{BB962C8B-B14F-4D97-AF65-F5344CB8AC3E}">
-        <p14:creationId xmlns:p14="http://schemas.microsoft.com/office/powerpoint/2010/main" val="3032562648"/>
+        <p14:creationId xmlns:p14="http://schemas.microsoft.com/office/powerpoint/2010/main" val="984374411"/>
       </p:ext>
     </p:extLst>
   </p:cSld>
@@ -9902,6 +10021,23 @@
                   </a:schemeClr>
                 </a:solidFill>
               </a:rPr>
+              <a:t>(100 Hz, 12dB)</a:t>
+            </a:r>
+          </a:p>
+          <a:p>
+            <a:pPr marL="285750" indent="-285750">
+              <a:buFontTx/>
+              <a:buChar char="-"/>
+            </a:pPr>
+            <a:r>
+              <a:rPr lang="en-GB" dirty="0">
+                <a:solidFill>
+                  <a:schemeClr val="tx1">
+                    <a:lumMod val="75000"/>
+                    <a:lumOff val="25000"/>
+                  </a:schemeClr>
+                </a:solidFill>
+              </a:rPr>
               <a:t>Compressed Audio to add impact:</a:t>
             </a:r>
           </a:p>
@@ -9989,7 +10125,7 @@
                   </a:schemeClr>
                 </a:solidFill>
               </a:rPr>
-              <a:t>Normalised perceived loudness to -30 dB</a:t>
+              <a:t>Normalised perceived loudness to -23 dB</a:t>
             </a:r>
           </a:p>
           <a:p>
@@ -10336,7 +10472,7 @@
         </p:blipFill>
         <p:spPr>
           <a:xfrm>
-            <a:off x="798576" y="4162957"/>
+            <a:off x="675068" y="4408729"/>
             <a:ext cx="2371408" cy="1174702"/>
           </a:xfrm>
           <a:prstGeom prst="rect">
@@ -10551,7 +10687,7 @@
                   </a:schemeClr>
                 </a:solidFill>
               </a:rPr>
-              <a:t>Low pass filter to remove any birds / grass crunches</a:t>
+              <a:t>Low pass filter to remove any birds / grass crunches (900 Hz, 6 dB)</a:t>
             </a:r>
           </a:p>
           <a:p>

</xml_diff>